<commit_message>
Daily rebuild Tue 05/19/2026  5:55:38.03
</commit_message>
<xml_diff>
--- a/generated/Tier 1 Broker Scorecards/3321 Group L.L.C_Broker_Scorecard.pptx
+++ b/generated/Tier 1 Broker Scorecards/3321 Group L.L.C_Broker_Scorecard.pptx
@@ -4664,7 +4664,7 @@
                         <a:rPr sz="800">
                           <a:latin typeface="Segoe UI"/>
                         </a:rPr>
-                        <a:t>17.5%</a:t>
+                        <a:t>18.4%</a:t>
                       </a:r>
                     </a:p>
                   </a:txBody>
@@ -4747,7 +4747,7 @@
                         <a:rPr sz="800">
                           <a:latin typeface="Segoe UI"/>
                         </a:rPr>
-                        <a:t>25.6%</a:t>
+                        <a:t>28.0%</a:t>
                       </a:r>
                     </a:p>
                   </a:txBody>
@@ -4943,7 +4943,7 @@
                         <a:rPr sz="800">
                           <a:latin typeface="Segoe UI"/>
                         </a:rPr>
-                        <a:t>18</a:t>
+                        <a:t>19</a:t>
                       </a:r>
                     </a:p>
                   </a:txBody>
@@ -5020,7 +5020,7 @@
                         <a:rPr sz="800">
                           <a:latin typeface="Segoe UI"/>
                         </a:rPr>
-                        <a:t>21</a:t>
+                        <a:t>23</a:t>
                       </a:r>
                     </a:p>
                   </a:txBody>

</xml_diff>

<commit_message>
Daily rebuild Wed 05/20/2026  8:00:08.03
</commit_message>
<xml_diff>
--- a/generated/Tier 1 Broker Scorecards/3321 Group L.L.C_Broker_Scorecard.pptx
+++ b/generated/Tier 1 Broker Scorecards/3321 Group L.L.C_Broker_Scorecard.pptx
@@ -4428,7 +4428,7 @@
                           </a:solidFill>
                           <a:latin typeface="Segoe UI"/>
                         </a:rPr>
-                        <a:t>6</a:t>
+                        <a:t>7</a:t>
                       </a:r>
                     </a:p>
                   </a:txBody>
@@ -4581,7 +4581,7 @@
                         <a:rPr sz="800">
                           <a:latin typeface="Segoe UI"/>
                         </a:rPr>
-                        <a:t>14.0%</a:t>
+                        <a:t>14.7%</a:t>
                       </a:r>
                     </a:p>
                   </a:txBody>
@@ -4707,7 +4707,7 @@
                           </a:solidFill>
                           <a:latin typeface="Segoe UI"/>
                         </a:rPr>
-                        <a:t>33.3%</a:t>
+                        <a:t>28.6%</a:t>
                       </a:r>
                     </a:p>
                   </a:txBody>
@@ -4747,7 +4747,7 @@
                         <a:rPr sz="800">
                           <a:latin typeface="Segoe UI"/>
                         </a:rPr>
-                        <a:t>28.0%</a:t>
+                        <a:t>26.8%</a:t>
                       </a:r>
                     </a:p>
                   </a:txBody>
@@ -4866,7 +4866,7 @@
                         <a:rPr sz="800">
                           <a:latin typeface="Segoe UI"/>
                         </a:rPr>
-                        <a:t>19</a:t>
+                        <a:t>20</a:t>
                       </a:r>
                     </a:p>
                   </a:txBody>
@@ -5020,7 +5020,7 @@
                         <a:rPr sz="800">
                           <a:latin typeface="Segoe UI"/>
                         </a:rPr>
-                        <a:t>23</a:t>
+                        <a:t>22</a:t>
                       </a:r>
                     </a:p>
                   </a:txBody>

</xml_diff>

<commit_message>
Daily rebuild Thu 05/21/2026  5:56:59.75
</commit_message>
<xml_diff>
--- a/generated/Tier 1 Broker Scorecards/3321 Group L.L.C_Broker_Scorecard.pptx
+++ b/generated/Tier 1 Broker Scorecards/3321 Group L.L.C_Broker_Scorecard.pptx
@@ -4428,7 +4428,7 @@
                           </a:solidFill>
                           <a:latin typeface="Segoe UI"/>
                         </a:rPr>
-                        <a:t>7</a:t>
+                        <a:t>8</a:t>
                       </a:r>
                     </a:p>
                   </a:txBody>
@@ -4581,7 +4581,7 @@
                         <a:rPr sz="800">
                           <a:latin typeface="Segoe UI"/>
                         </a:rPr>
-                        <a:t>14.7%</a:t>
+                        <a:t>14.0%</a:t>
                       </a:r>
                     </a:p>
                   </a:txBody>
@@ -4664,7 +4664,7 @@
                         <a:rPr sz="800">
                           <a:latin typeface="Segoe UI"/>
                         </a:rPr>
-                        <a:t>18.4%</a:t>
+                        <a:t>17.5%</a:t>
                       </a:r>
                     </a:p>
                   </a:txBody>
@@ -4707,7 +4707,7 @@
                           </a:solidFill>
                           <a:latin typeface="Segoe UI"/>
                         </a:rPr>
-                        <a:t>28.6%</a:t>
+                        <a:t>25.0%</a:t>
                       </a:r>
                     </a:p>
                   </a:txBody>
@@ -4747,7 +4747,7 @@
                         <a:rPr sz="800">
                           <a:latin typeface="Segoe UI"/>
                         </a:rPr>
-                        <a:t>26.8%</a:t>
+                        <a:t>28.0%</a:t>
                       </a:r>
                     </a:p>
                   </a:txBody>
@@ -4866,7 +4866,7 @@
                         <a:rPr sz="800">
                           <a:latin typeface="Segoe UI"/>
                         </a:rPr>
-                        <a:t>20</a:t>
+                        <a:t>19</a:t>
                       </a:r>
                     </a:p>
                   </a:txBody>
@@ -4943,7 +4943,7 @@
                         <a:rPr sz="800">
                           <a:latin typeface="Segoe UI"/>
                         </a:rPr>
-                        <a:t>19</a:t>
+                        <a:t>18</a:t>
                       </a:r>
                     </a:p>
                   </a:txBody>
@@ -5020,7 +5020,7 @@
                         <a:rPr sz="800">
                           <a:latin typeface="Segoe UI"/>
                         </a:rPr>
-                        <a:t>22</a:t>
+                        <a:t>23</a:t>
                       </a:r>
                     </a:p>
                   </a:txBody>

</xml_diff>

<commit_message>
Daily rebuild Fri 05/22/2026  9:38:40.72
</commit_message>
<xml_diff>
--- a/generated/Tier 1 Broker Scorecards/3321 Group L.L.C_Broker_Scorecard.pptx
+++ b/generated/Tier 1 Broker Scorecards/3321 Group L.L.C_Broker_Scorecard.pptx
@@ -3394,7 +3394,7 @@
                         <a:rPr sz="900">
                           <a:latin typeface="Segoe UI"/>
                         </a:rPr>
-                        <a:t>Tier 1  |  8.53% / 15.00%</a:t>
+                        <a:t>Tier 1  |  6.87% / 15.00%</a:t>
                       </a:r>
                     </a:p>
                   </a:txBody>
@@ -3766,7 +3766,7 @@
                         <a:rPr sz="900">
                           <a:latin typeface="Segoe UI"/>
                         </a:rPr>
-                        <a:t>Non-Fleet Subs: 124  |  Binds: 11</a:t>
+                        <a:t>Non-Fleet Subs: 126  |  Binds: 9</a:t>
                       </a:r>
                     </a:p>
                   </a:txBody>
@@ -4428,7 +4428,7 @@
                           </a:solidFill>
                           <a:latin typeface="Segoe UI"/>
                         </a:rPr>
-                        <a:t>8</a:t>
+                        <a:t>10</a:t>
                       </a:r>
                     </a:p>
                   </a:txBody>
@@ -4707,7 +4707,7 @@
                           </a:solidFill>
                           <a:latin typeface="Segoe UI"/>
                         </a:rPr>
-                        <a:t>25.0%</a:t>
+                        <a:t>20.0%</a:t>
                       </a:r>
                     </a:p>
                   </a:txBody>
@@ -4747,7 +4747,7 @@
                         <a:rPr sz="800">
                           <a:latin typeface="Segoe UI"/>
                         </a:rPr>
-                        <a:t>28.0%</a:t>
+                        <a:t>25.6%</a:t>
                       </a:r>
                     </a:p>
                   </a:txBody>
@@ -5020,7 +5020,7 @@
                         <a:rPr sz="800">
                           <a:latin typeface="Segoe UI"/>
                         </a:rPr>
-                        <a:t>23</a:t>
+                        <a:t>21</a:t>
                       </a:r>
                     </a:p>
                   </a:txBody>

</xml_diff>

<commit_message>
Daily rebuild Sat 05/23/2026 13:55:27.22
</commit_message>
<xml_diff>
--- a/generated/Tier 1 Broker Scorecards/3321 Group L.L.C_Broker_Scorecard.pptx
+++ b/generated/Tier 1 Broker Scorecards/3321 Group L.L.C_Broker_Scorecard.pptx
@@ -3394,7 +3394,7 @@
                         <a:rPr sz="900">
                           <a:latin typeface="Segoe UI"/>
                         </a:rPr>
-                        <a:t>Tier 1  |  6.87% / 15.00%</a:t>
+                        <a:t>Tier 1  |  7.58% / 15.00%</a:t>
                       </a:r>
                     </a:p>
                   </a:txBody>
@@ -3766,7 +3766,7 @@
                         <a:rPr sz="900">
                           <a:latin typeface="Segoe UI"/>
                         </a:rPr>
-                        <a:t>Non-Fleet Subs: 126  |  Binds: 9</a:t>
+                        <a:t>Non-Fleet Subs: 127  |  Binds: 10</a:t>
                       </a:r>
                     </a:p>
                   </a:txBody>
@@ -4428,7 +4428,7 @@
                           </a:solidFill>
                           <a:latin typeface="Segoe UI"/>
                         </a:rPr>
-                        <a:t>10</a:t>
+                        <a:t>11</a:t>
                       </a:r>
                     </a:p>
                   </a:txBody>
@@ -4581,7 +4581,7 @@
                         <a:rPr sz="800">
                           <a:latin typeface="Segoe UI"/>
                         </a:rPr>
-                        <a:t>14.0%</a:t>
+                        <a:t>14.7%</a:t>
                       </a:r>
                     </a:p>
                   </a:txBody>
@@ -4707,7 +4707,7 @@
                           </a:solidFill>
                           <a:latin typeface="Segoe UI"/>
                         </a:rPr>
-                        <a:t>20.0%</a:t>
+                        <a:t>18.2%</a:t>
                       </a:r>
                     </a:p>
                   </a:txBody>
@@ -4747,7 +4747,7 @@
                         <a:rPr sz="800">
                           <a:latin typeface="Segoe UI"/>
                         </a:rPr>
-                        <a:t>25.6%</a:t>
+                        <a:t>26.8%</a:t>
                       </a:r>
                     </a:p>
                   </a:txBody>
@@ -4866,7 +4866,7 @@
                         <a:rPr sz="800">
                           <a:latin typeface="Segoe UI"/>
                         </a:rPr>
-                        <a:t>19</a:t>
+                        <a:t>20</a:t>
                       </a:r>
                     </a:p>
                   </a:txBody>
@@ -5020,7 +5020,7 @@
                         <a:rPr sz="800">
                           <a:latin typeface="Segoe UI"/>
                         </a:rPr>
-                        <a:t>21</a:t>
+                        <a:t>22</a:t>
                       </a:r>
                     </a:p>
                   </a:txBody>

</xml_diff>

<commit_message>
Daily rebuild Mon 05/25/2026  9:28:29.42
</commit_message>
<xml_diff>
--- a/generated/Tier 1 Broker Scorecards/3321 Group L.L.C_Broker_Scorecard.pptx
+++ b/generated/Tier 1 Broker Scorecards/3321 Group L.L.C_Broker_Scorecard.pptx
@@ -4581,7 +4581,7 @@
                         <a:rPr sz="800">
                           <a:latin typeface="Segoe UI"/>
                         </a:rPr>
-                        <a:t>14.0%</a:t>
+                        <a:t>14.7%</a:t>
                       </a:r>
                     </a:p>
                   </a:txBody>
@@ -4747,7 +4747,7 @@
                         <a:rPr sz="800">
                           <a:latin typeface="Segoe UI"/>
                         </a:rPr>
-                        <a:t>26.8%</a:t>
+                        <a:t>25.6%</a:t>
                       </a:r>
                     </a:p>
                   </a:txBody>
@@ -4866,7 +4866,7 @@
                         <a:rPr sz="800">
                           <a:latin typeface="Segoe UI"/>
                         </a:rPr>
-                        <a:t>19</a:t>
+                        <a:t>20</a:t>
                       </a:r>
                     </a:p>
                   </a:txBody>
@@ -5020,7 +5020,7 @@
                         <a:rPr sz="800">
                           <a:latin typeface="Segoe UI"/>
                         </a:rPr>
-                        <a:t>22</a:t>
+                        <a:t>21</a:t>
                       </a:r>
                     </a:p>
                   </a:txBody>

</xml_diff>

<commit_message>
Daily rebuild Wed 05/27/2026  9:00:55.00
</commit_message>
<xml_diff>
--- a/generated/Tier 1 Broker Scorecards/3321 Group L.L.C_Broker_Scorecard.pptx
+++ b/generated/Tier 1 Broker Scorecards/3321 Group L.L.C_Broker_Scorecard.pptx
@@ -3394,7 +3394,7 @@
                         <a:rPr sz="900">
                           <a:latin typeface="Segoe UI"/>
                         </a:rPr>
-                        <a:t>Tier 1  |  6.82% / 15.00%</a:t>
+                        <a:t>Tier 1  |  8.15% / 15.00%</a:t>
                       </a:r>
                     </a:p>
                   </a:txBody>
@@ -3653,7 +3653,7 @@
                         <a:rPr sz="900">
                           <a:latin typeface="Segoe UI"/>
                         </a:rPr>
-                        <a:t>Fleet Subs: 5  |  Binds: 0</a:t>
+                        <a:t>Fleet Subs: 6  |  Binds: 1</a:t>
                       </a:r>
                     </a:p>
                   </a:txBody>
@@ -3690,7 +3690,7 @@
                         <a:rPr sz="900">
                           <a:latin typeface="Segoe UI"/>
                         </a:rPr>
-                        <a:t>Fleet Bound Premium: $0.00</a:t>
+                        <a:t>Fleet Bound Premium: $39,006.60</a:t>
                       </a:r>
                     </a:p>
                   </a:txBody>
@@ -3727,7 +3727,7 @@
                         <a:rPr sz="900">
                           <a:latin typeface="Segoe UI"/>
                         </a:rPr>
-                        <a:t>Fleet Book %: 0.0%</a:t>
+                        <a:t>Fleet Book %: 28.5%</a:t>
                       </a:r>
                     </a:p>
                   </a:txBody>
@@ -3766,7 +3766,7 @@
                         <a:rPr sz="900">
                           <a:latin typeface="Segoe UI"/>
                         </a:rPr>
-                        <a:t>Non-Fleet Subs: 127  |  Binds: 9</a:t>
+                        <a:t>Non-Fleet Subs: 129  |  Binds: 10</a:t>
                       </a:r>
                     </a:p>
                   </a:txBody>
@@ -3803,7 +3803,7 @@
                         <a:rPr sz="900">
                           <a:latin typeface="Segoe UI"/>
                         </a:rPr>
-                        <a:t>Non-Fleet Bound Premium: $136,698.87</a:t>
+                        <a:t>Non-Fleet Bound Premium: $97,692.27</a:t>
                       </a:r>
                     </a:p>
                   </a:txBody>
@@ -3840,7 +3840,7 @@
                         <a:rPr sz="900">
                           <a:latin typeface="Segoe UI"/>
                         </a:rPr>
-                        <a:t>Non-Fleet Book %: 100.0%</a:t>
+                        <a:t>Non-Fleet Book %: 71.5%</a:t>
                       </a:r>
                     </a:p>
                   </a:txBody>
@@ -4428,7 +4428,7 @@
                           </a:solidFill>
                           <a:latin typeface="Segoe UI"/>
                         </a:rPr>
-                        <a:t>11</a:t>
+                        <a:t>14</a:t>
                       </a:r>
                     </a:p>
                   </a:txBody>
@@ -4703,11 +4703,11 @@
                       <a:r>
                         <a:rPr sz="800">
                           <a:solidFill>
-                            <a:srgbClr val="059669"/>
+                            <a:srgbClr val="DC2626"/>
                           </a:solidFill>
                           <a:latin typeface="Segoe UI"/>
                         </a:rPr>
-                        <a:t>18.2%</a:t>
+                        <a:t>14.3%</a:t>
                       </a:r>
                     </a:p>
                   </a:txBody>

</xml_diff>

<commit_message>
Daily rebuild Thu 05/28/2026  5:34:14.08
</commit_message>
<xml_diff>
--- a/generated/Tier 1 Broker Scorecards/3321 Group L.L.C_Broker_Scorecard.pptx
+++ b/generated/Tier 1 Broker Scorecards/3321 Group L.L.C_Broker_Scorecard.pptx
@@ -3690,7 +3690,7 @@
                         <a:rPr sz="900">
                           <a:latin typeface="Segoe UI"/>
                         </a:rPr>
-                        <a:t>Fleet Bound Premium: $39,006.60</a:t>
+                        <a:t>Fleet Bound Premium: $37,828.02</a:t>
                       </a:r>
                     </a:p>
                   </a:txBody>
@@ -3727,7 +3727,7 @@
                         <a:rPr sz="900">
                           <a:latin typeface="Segoe UI"/>
                         </a:rPr>
-                        <a:t>Fleet Book %: 28.5%</a:t>
+                        <a:t>Fleet Book %: 27.7%</a:t>
                       </a:r>
                     </a:p>
                   </a:txBody>
@@ -3803,7 +3803,7 @@
                         <a:rPr sz="900">
                           <a:latin typeface="Segoe UI"/>
                         </a:rPr>
-                        <a:t>Non-Fleet Bound Premium: $97,692.27</a:t>
+                        <a:t>Non-Fleet Bound Premium: $98,870.85</a:t>
                       </a:r>
                     </a:p>
                   </a:txBody>
@@ -3840,7 +3840,7 @@
                         <a:rPr sz="900">
                           <a:latin typeface="Segoe UI"/>
                         </a:rPr>
-                        <a:t>Non-Fleet Book %: 71.5%</a:t>
+                        <a:t>Non-Fleet Book %: 72.3%</a:t>
                       </a:r>
                     </a:p>
                   </a:txBody>
@@ -4428,7 +4428,7 @@
                           </a:solidFill>
                           <a:latin typeface="Segoe UI"/>
                         </a:rPr>
-                        <a:t>14</a:t>
+                        <a:t>16</a:t>
                       </a:r>
                     </a:p>
                   </a:txBody>
@@ -4581,7 +4581,7 @@
                         <a:rPr sz="800">
                           <a:latin typeface="Segoe UI"/>
                         </a:rPr>
-                        <a:t>14.0%</a:t>
+                        <a:t>14.7%</a:t>
                       </a:r>
                     </a:p>
                   </a:txBody>
@@ -4664,7 +4664,7 @@
                         <a:rPr sz="800">
                           <a:latin typeface="Segoe UI"/>
                         </a:rPr>
-                        <a:t>17.5%</a:t>
+                        <a:t>18.4%</a:t>
                       </a:r>
                     </a:p>
                   </a:txBody>
@@ -4707,7 +4707,7 @@
                           </a:solidFill>
                           <a:latin typeface="Segoe UI"/>
                         </a:rPr>
-                        <a:t>14.3%</a:t>
+                        <a:t>12.5%</a:t>
                       </a:r>
                     </a:p>
                   </a:txBody>
@@ -4747,7 +4747,7 @@
                         <a:rPr sz="800">
                           <a:latin typeface="Segoe UI"/>
                         </a:rPr>
-                        <a:t>26.8%</a:t>
+                        <a:t>25.6%</a:t>
                       </a:r>
                     </a:p>
                   </a:txBody>
@@ -4866,7 +4866,7 @@
                         <a:rPr sz="800">
                           <a:latin typeface="Segoe UI"/>
                         </a:rPr>
-                        <a:t>19</a:t>
+                        <a:t>20</a:t>
                       </a:r>
                     </a:p>
                   </a:txBody>
@@ -4943,7 +4943,7 @@
                         <a:rPr sz="800">
                           <a:latin typeface="Segoe UI"/>
                         </a:rPr>
-                        <a:t>18</a:t>
+                        <a:t>19</a:t>
                       </a:r>
                     </a:p>
                   </a:txBody>
@@ -5020,7 +5020,7 @@
                         <a:rPr sz="800">
                           <a:latin typeface="Segoe UI"/>
                         </a:rPr>
-                        <a:t>22</a:t>
+                        <a:t>21</a:t>
                       </a:r>
                     </a:p>
                   </a:txBody>

</xml_diff>

<commit_message>
Daily rebuild Fri 05/29/2026  5:36:51.78
</commit_message>
<xml_diff>
--- a/generated/Tier 1 Broker Scorecards/3321 Group L.L.C_Broker_Scorecard.pptx
+++ b/generated/Tier 1 Broker Scorecards/3321 Group L.L.C_Broker_Scorecard.pptx
@@ -3394,7 +3394,7 @@
                         <a:rPr sz="900">
                           <a:latin typeface="Segoe UI"/>
                         </a:rPr>
-                        <a:t>Tier 1  |  8.15% / 15.00%</a:t>
+                        <a:t>Tier 1  |  6.47% / 15.00%</a:t>
                       </a:r>
                     </a:p>
                   </a:txBody>
@@ -3690,7 +3690,7 @@
                         <a:rPr sz="900">
                           <a:latin typeface="Segoe UI"/>
                         </a:rPr>
-                        <a:t>Fleet Bound Premium: $37,828.02</a:t>
+                        <a:t>Fleet Bound Premium: $43,076.99</a:t>
                       </a:r>
                     </a:p>
                   </a:txBody>
@@ -3727,7 +3727,7 @@
                         <a:rPr sz="900">
                           <a:latin typeface="Segoe UI"/>
                         </a:rPr>
-                        <a:t>Fleet Book %: 27.7%</a:t>
+                        <a:t>Fleet Book %: 31.5%</a:t>
                       </a:r>
                     </a:p>
                   </a:txBody>
@@ -3766,7 +3766,7 @@
                         <a:rPr sz="900">
                           <a:latin typeface="Segoe UI"/>
                         </a:rPr>
-                        <a:t>Non-Fleet Subs: 129  |  Binds: 10</a:t>
+                        <a:t>Non-Fleet Subs: 133  |  Binds: 8</a:t>
                       </a:r>
                     </a:p>
                   </a:txBody>
@@ -3803,7 +3803,7 @@
                         <a:rPr sz="900">
                           <a:latin typeface="Segoe UI"/>
                         </a:rPr>
-                        <a:t>Non-Fleet Bound Premium: $98,870.85</a:t>
+                        <a:t>Non-Fleet Bound Premium: $93,621.88</a:t>
                       </a:r>
                     </a:p>
                   </a:txBody>
@@ -3840,7 +3840,7 @@
                         <a:rPr sz="900">
                           <a:latin typeface="Segoe UI"/>
                         </a:rPr>
-                        <a:t>Non-Fleet Book %: 72.3%</a:t>
+                        <a:t>Non-Fleet Book %: 68.5%</a:t>
                       </a:r>
                     </a:p>
                   </a:txBody>
@@ -4428,7 +4428,7 @@
                           </a:solidFill>
                           <a:latin typeface="Segoe UI"/>
                         </a:rPr>
-                        <a:t>16</a:t>
+                        <a:t>20</a:t>
                       </a:r>
                     </a:p>
                   </a:txBody>
@@ -4707,7 +4707,7 @@
                           </a:solidFill>
                           <a:latin typeface="Segoe UI"/>
                         </a:rPr>
-                        <a:t>12.5%</a:t>
+                        <a:t>10.0%</a:t>
                       </a:r>
                     </a:p>
                   </a:txBody>
@@ -4747,7 +4747,7 @@
                         <a:rPr sz="800">
                           <a:latin typeface="Segoe UI"/>
                         </a:rPr>
-                        <a:t>25.6%</a:t>
+                        <a:t>28.0%</a:t>
                       </a:r>
                     </a:p>
                   </a:txBody>
@@ -5020,7 +5020,7 @@
                         <a:rPr sz="800">
                           <a:latin typeface="Segoe UI"/>
                         </a:rPr>
-                        <a:t>21</a:t>
+                        <a:t>23</a:t>
                       </a:r>
                     </a:p>
                   </a:txBody>

</xml_diff>

<commit_message>
Daily rebuild Mon 06/01/2026  9:40:20.71
</commit_message>
<xml_diff>
--- a/generated/Tier 1 Broker Scorecards/3321 Group L.L.C_Broker_Scorecard.pptx
+++ b/generated/Tier 1 Broker Scorecards/3321 Group L.L.C_Broker_Scorecard.pptx
@@ -3357,7 +3357,7 @@
                         <a:rPr sz="800">
                           <a:latin typeface="Segoe UI"/>
                         </a:rPr>
-                        <a:t>$2,228,375.71 / $1,071,037.81 / $136,698.87</a:t>
+                        <a:t>$2,228,375.71 / $823,368.39 / $136,698.87</a:t>
                       </a:r>
                     </a:p>
                   </a:txBody>
@@ -3394,7 +3394,7 @@
                         <a:rPr sz="900">
                           <a:latin typeface="Segoe UI"/>
                         </a:rPr>
-                        <a:t>Tier 1  |  7.09% / 15.00%</a:t>
+                        <a:t>Tier 1  |  7.80% / 15.00%</a:t>
                       </a:r>
                     </a:p>
                   </a:txBody>
@@ -3690,7 +3690,7 @@
                         <a:rPr sz="900">
                           <a:latin typeface="Segoe UI"/>
                         </a:rPr>
-                        <a:t>Fleet Bound Premium: $40,855.76</a:t>
+                        <a:t>Fleet Bound Premium: $37,828.02</a:t>
                       </a:r>
                     </a:p>
                   </a:txBody>
@@ -3727,7 +3727,7 @@
                         <a:rPr sz="900">
                           <a:latin typeface="Segoe UI"/>
                         </a:rPr>
-                        <a:t>Fleet Book %: 29.9%</a:t>
+                        <a:t>Fleet Book %: 27.7%</a:t>
                       </a:r>
                     </a:p>
                   </a:txBody>
@@ -3766,7 +3766,7 @@
                         <a:rPr sz="900">
                           <a:latin typeface="Segoe UI"/>
                         </a:rPr>
-                        <a:t>Non-Fleet Subs: 135  |  Binds: 9</a:t>
+                        <a:t>Non-Fleet Subs: 135  |  Binds: 10</a:t>
                       </a:r>
                     </a:p>
                   </a:txBody>
@@ -3803,7 +3803,7 @@
                         <a:rPr sz="900">
                           <a:latin typeface="Segoe UI"/>
                         </a:rPr>
-                        <a:t>Non-Fleet Bound Premium: $95,843.11</a:t>
+                        <a:t>Non-Fleet Bound Premium: $98,870.85</a:t>
                       </a:r>
                     </a:p>
                   </a:txBody>
@@ -3840,7 +3840,7 @@
                         <a:rPr sz="900">
                           <a:latin typeface="Segoe UI"/>
                         </a:rPr>
-                        <a:t>Non-Fleet Book %: 70.1%</a:t>
+                        <a:t>Non-Fleet Book %: 72.3%</a:t>
                       </a:r>
                     </a:p>
                   </a:txBody>
@@ -4581,7 +4581,7 @@
                         <a:rPr sz="800">
                           <a:latin typeface="Segoe UI"/>
                         </a:rPr>
-                        <a:t>14.0%</a:t>
+                        <a:t>14.7%</a:t>
                       </a:r>
                     </a:p>
                   </a:txBody>
@@ -4664,7 +4664,7 @@
                         <a:rPr sz="800">
                           <a:latin typeface="Segoe UI"/>
                         </a:rPr>
-                        <a:t>17.5%</a:t>
+                        <a:t>18.4%</a:t>
                       </a:r>
                     </a:p>
                   </a:txBody>
@@ -4866,7 +4866,7 @@
                         <a:rPr sz="800">
                           <a:latin typeface="Segoe UI"/>
                         </a:rPr>
-                        <a:t>19</a:t>
+                        <a:t>20</a:t>
                       </a:r>
                     </a:p>
                   </a:txBody>
@@ -4943,7 +4943,7 @@
                         <a:rPr sz="800">
                           <a:latin typeface="Segoe UI"/>
                         </a:rPr>
-                        <a:t>18</a:t>
+                        <a:t>19</a:t>
                       </a:r>
                     </a:p>
                   </a:txBody>

</xml_diff>